<commit_message>
Admin.App: AutoComplete, DbParentTable using DbPrefix, powershell script CleanBuildDirectories
</commit_message>
<xml_diff>
--- a/Admin/Docs.pptx
+++ b/Admin/Docs.pptx
@@ -285,7 +285,7 @@
           <a:p>
             <a:fld id="{5AD74501-8691-4646-B472-1139202FB98B}" type="datetimeFigureOut">
               <a:rPr lang="en-US" smtClean="0"/>
-              <a:t>4/2/2026</a:t>
+              <a:t>4/12/2026</a:t>
             </a:fld>
             <a:endParaRPr lang="en-US"/>
           </a:p>
@@ -483,7 +483,7 @@
           <a:p>
             <a:fld id="{5AD74501-8691-4646-B472-1139202FB98B}" type="datetimeFigureOut">
               <a:rPr lang="en-US" smtClean="0"/>
-              <a:t>4/2/2026</a:t>
+              <a:t>4/12/2026</a:t>
             </a:fld>
             <a:endParaRPr lang="en-US"/>
           </a:p>
@@ -691,7 +691,7 @@
           <a:p>
             <a:fld id="{5AD74501-8691-4646-B472-1139202FB98B}" type="datetimeFigureOut">
               <a:rPr lang="en-US" smtClean="0"/>
-              <a:t>4/2/2026</a:t>
+              <a:t>4/12/2026</a:t>
             </a:fld>
             <a:endParaRPr lang="en-US"/>
           </a:p>
@@ -889,7 +889,7 @@
           <a:p>
             <a:fld id="{5AD74501-8691-4646-B472-1139202FB98B}" type="datetimeFigureOut">
               <a:rPr lang="en-US" smtClean="0"/>
-              <a:t>4/2/2026</a:t>
+              <a:t>4/12/2026</a:t>
             </a:fld>
             <a:endParaRPr lang="en-US"/>
           </a:p>
@@ -1164,7 +1164,7 @@
           <a:p>
             <a:fld id="{5AD74501-8691-4646-B472-1139202FB98B}" type="datetimeFigureOut">
               <a:rPr lang="en-US" smtClean="0"/>
-              <a:t>4/2/2026</a:t>
+              <a:t>4/12/2026</a:t>
             </a:fld>
             <a:endParaRPr lang="en-US"/>
           </a:p>
@@ -1429,7 +1429,7 @@
           <a:p>
             <a:fld id="{5AD74501-8691-4646-B472-1139202FB98B}" type="datetimeFigureOut">
               <a:rPr lang="en-US" smtClean="0"/>
-              <a:t>4/2/2026</a:t>
+              <a:t>4/12/2026</a:t>
             </a:fld>
             <a:endParaRPr lang="en-US"/>
           </a:p>
@@ -1841,7 +1841,7 @@
           <a:p>
             <a:fld id="{5AD74501-8691-4646-B472-1139202FB98B}" type="datetimeFigureOut">
               <a:rPr lang="en-US" smtClean="0"/>
-              <a:t>4/2/2026</a:t>
+              <a:t>4/12/2026</a:t>
             </a:fld>
             <a:endParaRPr lang="en-US"/>
           </a:p>
@@ -1982,7 +1982,7 @@
           <a:p>
             <a:fld id="{5AD74501-8691-4646-B472-1139202FB98B}" type="datetimeFigureOut">
               <a:rPr lang="en-US" smtClean="0"/>
-              <a:t>4/2/2026</a:t>
+              <a:t>4/12/2026</a:t>
             </a:fld>
             <a:endParaRPr lang="en-US"/>
           </a:p>
@@ -2095,7 +2095,7 @@
           <a:p>
             <a:fld id="{5AD74501-8691-4646-B472-1139202FB98B}" type="datetimeFigureOut">
               <a:rPr lang="en-US" smtClean="0"/>
-              <a:t>4/2/2026</a:t>
+              <a:t>4/12/2026</a:t>
             </a:fld>
             <a:endParaRPr lang="en-US"/>
           </a:p>
@@ -2406,7 +2406,7 @@
           <a:p>
             <a:fld id="{5AD74501-8691-4646-B472-1139202FB98B}" type="datetimeFigureOut">
               <a:rPr lang="en-US" smtClean="0"/>
-              <a:t>4/2/2026</a:t>
+              <a:t>4/12/2026</a:t>
             </a:fld>
             <a:endParaRPr lang="en-US"/>
           </a:p>
@@ -2694,7 +2694,7 @@
           <a:p>
             <a:fld id="{5AD74501-8691-4646-B472-1139202FB98B}" type="datetimeFigureOut">
               <a:rPr lang="en-US" smtClean="0"/>
-              <a:t>4/2/2026</a:t>
+              <a:t>4/12/2026</a:t>
             </a:fld>
             <a:endParaRPr lang="en-US"/>
           </a:p>
@@ -2935,7 +2935,7 @@
           <a:p>
             <a:fld id="{5AD74501-8691-4646-B472-1139202FB98B}" type="datetimeFigureOut">
               <a:rPr lang="en-US" smtClean="0"/>
-              <a:t>4/2/2026</a:t>
+              <a:t>4/12/2026</a:t>
             </a:fld>
             <a:endParaRPr lang="en-US"/>
           </a:p>
@@ -4932,247 +4932,268 @@
           <a:chExt cx="0" cy="0"/>
         </a:xfrm>
       </p:grpSpPr>
-      <p:sp>
-        <p:nvSpPr>
-          <p:cNvPr id="2" name="Freeform: Shape 1">
+      <p:grpSp>
+        <p:nvGrpSpPr>
+          <p:cNvPr id="3" name="Group 2">
             <a:extLst>
               <a:ext uri="{FF2B5EF4-FFF2-40B4-BE49-F238E27FC236}">
-                <a16:creationId xmlns:a16="http://schemas.microsoft.com/office/drawing/2014/main" id="{71EA1A43-1875-A8CC-5892-CACF650673D7}"/>
+                <a16:creationId xmlns:a16="http://schemas.microsoft.com/office/drawing/2014/main" id="{2DD7C84A-F75F-89CA-D929-982EE7B9F86E}"/>
               </a:ext>
             </a:extLst>
           </p:cNvPr>
-          <p:cNvSpPr/>
+          <p:cNvGrpSpPr/>
           <p:nvPr/>
-        </p:nvSpPr>
-        <p:spPr>
-          <a:xfrm>
-            <a:off x="4267106" y="552917"/>
-            <a:ext cx="7229138" cy="6228674"/>
-          </a:xfrm>
-          <a:custGeom>
-            <a:avLst/>
-            <a:gdLst>
-              <a:gd name="csX0" fmla="*/ -1 w 7229138"/>
-              <a:gd name="csY0" fmla="*/ 3114376 h 6228674"/>
-              <a:gd name="csX1" fmla="*/ 3614568 w 7229138"/>
-              <a:gd name="csY1" fmla="*/ 40 h 6228674"/>
-              <a:gd name="csX2" fmla="*/ 7229137 w 7229138"/>
-              <a:gd name="csY2" fmla="*/ 3114376 h 6228674"/>
-              <a:gd name="csX3" fmla="*/ 3614568 w 7229138"/>
-              <a:gd name="csY3" fmla="*/ 6228715 h 6228674"/>
-              <a:gd name="csX4" fmla="*/ -1 w 7229138"/>
-              <a:gd name="csY4" fmla="*/ 3114376 h 6228674"/>
-            </a:gdLst>
-            <a:ahLst/>
-            <a:cxnLst>
-              <a:cxn ang="0">
-                <a:pos x="csX0" y="csY0"/>
-              </a:cxn>
-              <a:cxn ang="0">
-                <a:pos x="csX1" y="csY1"/>
-              </a:cxn>
-              <a:cxn ang="0">
-                <a:pos x="csX2" y="csY2"/>
-              </a:cxn>
-              <a:cxn ang="0">
-                <a:pos x="csX3" y="csY3"/>
-              </a:cxn>
-              <a:cxn ang="0">
-                <a:pos x="csX4" y="csY4"/>
-              </a:cxn>
-            </a:cxnLst>
-            <a:rect l="l" t="t" r="r" b="b"/>
-            <a:pathLst>
-              <a:path w="7229138" h="6228674">
-                <a:moveTo>
-                  <a:pt x="-1" y="3114376"/>
-                </a:moveTo>
-                <a:cubicBezTo>
-                  <a:pt x="-1" y="1394373"/>
-                  <a:pt x="1618301" y="40"/>
-                  <a:pt x="3614568" y="40"/>
-                </a:cubicBezTo>
-                <a:cubicBezTo>
-                  <a:pt x="5610843" y="40"/>
-                  <a:pt x="7229137" y="1394373"/>
-                  <a:pt x="7229137" y="3114376"/>
-                </a:cubicBezTo>
-                <a:cubicBezTo>
-                  <a:pt x="7229137" y="4834378"/>
-                  <a:pt x="5610843" y="6228715"/>
-                  <a:pt x="3614568" y="6228715"/>
-                </a:cubicBezTo>
-                <a:cubicBezTo>
-                  <a:pt x="1618301" y="6228715"/>
-                  <a:pt x="-1" y="4834378"/>
-                  <a:pt x="-1" y="3114376"/>
-                </a:cubicBezTo>
-                <a:close/>
-              </a:path>
-            </a:pathLst>
-          </a:custGeom>
-          <a:solidFill>
-            <a:schemeClr val="accent5">
-              <a:lumMod val="50000"/>
-              <a:alpha val="15000"/>
-            </a:schemeClr>
-          </a:solidFill>
-          <a:ln w="8067" cap="flat">
-            <a:noFill/>
-            <a:prstDash val="solid"/>
-            <a:miter/>
-          </a:ln>
-        </p:spPr>
-        <p:txBody>
-          <a:bodyPr/>
-          <a:lstStyle/>
-          <a:p>
-            <a:endParaRPr lang="en-US"/>
-          </a:p>
-        </p:txBody>
-      </p:sp>
-      <p:sp>
-        <p:nvSpPr>
-          <p:cNvPr id="9" name="Freeform: Shape 8">
-            <a:extLst>
-              <a:ext uri="{FF2B5EF4-FFF2-40B4-BE49-F238E27FC236}">
-                <a16:creationId xmlns:a16="http://schemas.microsoft.com/office/drawing/2014/main" id="{1D9624A8-0D42-F92F-F643-EAA8B2D2EBE8}"/>
-              </a:ext>
-            </a:extLst>
-          </p:cNvPr>
-          <p:cNvSpPr/>
-          <p:nvPr/>
-        </p:nvSpPr>
-        <p:spPr>
+        </p:nvGrpSpPr>
+        <p:grpSpPr>
           <a:xfrm>
             <a:off x="4267106" y="72185"/>
-            <a:ext cx="7229139" cy="6228677"/>
+            <a:ext cx="7229139" cy="6709406"/>
+            <a:chOff x="4267106" y="72185"/>
+            <a:chExt cx="7229139" cy="6709406"/>
           </a:xfrm>
-          <a:custGeom>
-            <a:avLst/>
-            <a:gdLst>
-              <a:gd name="csX0" fmla="*/ -1371 w 7229139"/>
-              <a:gd name="csY0" fmla="*/ 3112940 h 6228677"/>
-              <a:gd name="csX1" fmla="*/ 3613199 w 7229139"/>
-              <a:gd name="csY1" fmla="*/ -1399 h 6228677"/>
-              <a:gd name="csX2" fmla="*/ 7227768 w 7229139"/>
-              <a:gd name="csY2" fmla="*/ 3112940 h 6228677"/>
-              <a:gd name="csX3" fmla="*/ 3613199 w 7229139"/>
-              <a:gd name="csY3" fmla="*/ 6227279 h 6228677"/>
-              <a:gd name="csX4" fmla="*/ -1371 w 7229139"/>
-              <a:gd name="csY4" fmla="*/ 3112940 h 6228677"/>
-            </a:gdLst>
-            <a:ahLst/>
-            <a:cxnLst>
-              <a:cxn ang="0">
-                <a:pos x="csX0" y="csY0"/>
-              </a:cxn>
-              <a:cxn ang="0">
-                <a:pos x="csX1" y="csY1"/>
-              </a:cxn>
-              <a:cxn ang="0">
-                <a:pos x="csX2" y="csY2"/>
-              </a:cxn>
-              <a:cxn ang="0">
-                <a:pos x="csX3" y="csY3"/>
-              </a:cxn>
-              <a:cxn ang="0">
-                <a:pos x="csX4" y="csY4"/>
-              </a:cxn>
-            </a:cxnLst>
-            <a:rect l="l" t="t" r="r" b="b"/>
-            <a:pathLst>
-              <a:path w="7229139" h="6228677">
-                <a:moveTo>
-                  <a:pt x="-1371" y="3112940"/>
-                </a:moveTo>
-                <a:cubicBezTo>
-                  <a:pt x="-1371" y="1392953"/>
-                  <a:pt x="1616955" y="-1399"/>
-                  <a:pt x="3613199" y="-1399"/>
-                </a:cubicBezTo>
-                <a:cubicBezTo>
-                  <a:pt x="5609441" y="-1399"/>
-                  <a:pt x="7227768" y="1392953"/>
-                  <a:pt x="7227768" y="3112940"/>
-                </a:cubicBezTo>
-                <a:cubicBezTo>
-                  <a:pt x="7227768" y="4832927"/>
-                  <a:pt x="5609441" y="6227279"/>
-                  <a:pt x="3613199" y="6227279"/>
-                </a:cubicBezTo>
-                <a:cubicBezTo>
-                  <a:pt x="1616955" y="6227279"/>
-                  <a:pt x="-1371" y="4832927"/>
-                  <a:pt x="-1371" y="3112940"/>
-                </a:cubicBezTo>
-                <a:close/>
-              </a:path>
-            </a:pathLst>
-          </a:custGeom>
-          <a:solidFill>
-            <a:schemeClr val="accent5">
-              <a:lumMod val="50000"/>
-              <a:alpha val="15000"/>
-            </a:schemeClr>
-          </a:solidFill>
-          <a:ln w="8067" cap="flat">
-            <a:noFill/>
-            <a:prstDash val="solid"/>
-            <a:miter/>
-          </a:ln>
-        </p:spPr>
-        <p:txBody>
-          <a:bodyPr/>
-          <a:lstStyle/>
-          <a:p>
-            <a:endParaRPr lang="en-US"/>
-          </a:p>
-        </p:txBody>
-      </p:sp>
-      <p:pic>
-        <p:nvPicPr>
-          <p:cNvPr id="71" name="Graphic 70" descr="Handshake outline">
-            <a:extLst>
-              <a:ext uri="{FF2B5EF4-FFF2-40B4-BE49-F238E27FC236}">
-                <a16:creationId xmlns:a16="http://schemas.microsoft.com/office/drawing/2014/main" id="{AA291953-9BBF-33E0-DF83-D81DD48CB98E}"/>
-              </a:ext>
-            </a:extLst>
-          </p:cNvPr>
-          <p:cNvPicPr>
-            <a:picLocks noChangeAspect="1"/>
-          </p:cNvPicPr>
-          <p:nvPr/>
-        </p:nvPicPr>
-        <p:blipFill>
-          <a:blip>
-            <a:extLst>
-              <a:ext uri="{96DAC541-7B7A-43D3-8B79-37D633B846F1}">
-                <asvg:svgBlip xmlns:asvg="http://schemas.microsoft.com/office/drawing/2016/SVG/main" r:embed="rId2"/>
-              </a:ext>
-            </a:extLst>
-          </a:blip>
-          <a:stretch>
-            <a:fillRect/>
-          </a:stretch>
-        </p:blipFill>
-        <p:spPr>
-          <a:xfrm>
-            <a:off x="5367075" y="914400"/>
-            <a:ext cx="5029200" cy="5029200"/>
-          </a:xfrm>
-          <a:prstGeom prst="rect">
-            <a:avLst/>
-          </a:prstGeom>
-          <a:effectLst>
-            <a:outerShdw blurRad="50800" dist="127000" dir="2700000" algn="tl" rotWithShape="0">
-              <a:schemeClr val="accent1">
-                <a:alpha val="40000"/>
+        </p:grpSpPr>
+        <p:sp>
+          <p:nvSpPr>
+            <p:cNvPr id="2" name="Freeform: Shape 1">
+              <a:extLst>
+                <a:ext uri="{FF2B5EF4-FFF2-40B4-BE49-F238E27FC236}">
+                  <a16:creationId xmlns:a16="http://schemas.microsoft.com/office/drawing/2014/main" id="{71EA1A43-1875-A8CC-5892-CACF650673D7}"/>
+                </a:ext>
+              </a:extLst>
+            </p:cNvPr>
+            <p:cNvSpPr/>
+            <p:nvPr/>
+          </p:nvSpPr>
+          <p:spPr>
+            <a:xfrm>
+              <a:off x="4267106" y="552917"/>
+              <a:ext cx="7229138" cy="6228674"/>
+            </a:xfrm>
+            <a:custGeom>
+              <a:avLst/>
+              <a:gdLst>
+                <a:gd name="csX0" fmla="*/ -1 w 7229138"/>
+                <a:gd name="csY0" fmla="*/ 3114376 h 6228674"/>
+                <a:gd name="csX1" fmla="*/ 3614568 w 7229138"/>
+                <a:gd name="csY1" fmla="*/ 40 h 6228674"/>
+                <a:gd name="csX2" fmla="*/ 7229137 w 7229138"/>
+                <a:gd name="csY2" fmla="*/ 3114376 h 6228674"/>
+                <a:gd name="csX3" fmla="*/ 3614568 w 7229138"/>
+                <a:gd name="csY3" fmla="*/ 6228715 h 6228674"/>
+                <a:gd name="csX4" fmla="*/ -1 w 7229138"/>
+                <a:gd name="csY4" fmla="*/ 3114376 h 6228674"/>
+              </a:gdLst>
+              <a:ahLst/>
+              <a:cxnLst>
+                <a:cxn ang="0">
+                  <a:pos x="csX0" y="csY0"/>
+                </a:cxn>
+                <a:cxn ang="0">
+                  <a:pos x="csX1" y="csY1"/>
+                </a:cxn>
+                <a:cxn ang="0">
+                  <a:pos x="csX2" y="csY2"/>
+                </a:cxn>
+                <a:cxn ang="0">
+                  <a:pos x="csX3" y="csY3"/>
+                </a:cxn>
+                <a:cxn ang="0">
+                  <a:pos x="csX4" y="csY4"/>
+                </a:cxn>
+              </a:cxnLst>
+              <a:rect l="l" t="t" r="r" b="b"/>
+              <a:pathLst>
+                <a:path w="7229138" h="6228674">
+                  <a:moveTo>
+                    <a:pt x="-1" y="3114376"/>
+                  </a:moveTo>
+                  <a:cubicBezTo>
+                    <a:pt x="-1" y="1394373"/>
+                    <a:pt x="1618301" y="40"/>
+                    <a:pt x="3614568" y="40"/>
+                  </a:cubicBezTo>
+                  <a:cubicBezTo>
+                    <a:pt x="5610843" y="40"/>
+                    <a:pt x="7229137" y="1394373"/>
+                    <a:pt x="7229137" y="3114376"/>
+                  </a:cubicBezTo>
+                  <a:cubicBezTo>
+                    <a:pt x="7229137" y="4834378"/>
+                    <a:pt x="5610843" y="6228715"/>
+                    <a:pt x="3614568" y="6228715"/>
+                  </a:cubicBezTo>
+                  <a:cubicBezTo>
+                    <a:pt x="1618301" y="6228715"/>
+                    <a:pt x="-1" y="4834378"/>
+                    <a:pt x="-1" y="3114376"/>
+                  </a:cubicBezTo>
+                  <a:close/>
+                </a:path>
+              </a:pathLst>
+            </a:custGeom>
+            <a:solidFill>
+              <a:schemeClr val="accent5">
+                <a:lumMod val="50000"/>
+                <a:alpha val="15000"/>
               </a:schemeClr>
-            </a:outerShdw>
-          </a:effectLst>
-        </p:spPr>
-      </p:pic>
+            </a:solidFill>
+            <a:ln w="8067" cap="flat">
+              <a:noFill/>
+              <a:prstDash val="solid"/>
+              <a:miter/>
+            </a:ln>
+          </p:spPr>
+          <p:txBody>
+            <a:bodyPr/>
+            <a:lstStyle/>
+            <a:p>
+              <a:endParaRPr lang="en-US"/>
+            </a:p>
+          </p:txBody>
+        </p:sp>
+        <p:sp>
+          <p:nvSpPr>
+            <p:cNvPr id="9" name="Freeform: Shape 8">
+              <a:extLst>
+                <a:ext uri="{FF2B5EF4-FFF2-40B4-BE49-F238E27FC236}">
+                  <a16:creationId xmlns:a16="http://schemas.microsoft.com/office/drawing/2014/main" id="{1D9624A8-0D42-F92F-F643-EAA8B2D2EBE8}"/>
+                </a:ext>
+              </a:extLst>
+            </p:cNvPr>
+            <p:cNvSpPr/>
+            <p:nvPr/>
+          </p:nvSpPr>
+          <p:spPr>
+            <a:xfrm>
+              <a:off x="4267106" y="72185"/>
+              <a:ext cx="7229139" cy="6228677"/>
+            </a:xfrm>
+            <a:custGeom>
+              <a:avLst/>
+              <a:gdLst>
+                <a:gd name="csX0" fmla="*/ -1371 w 7229139"/>
+                <a:gd name="csY0" fmla="*/ 3112940 h 6228677"/>
+                <a:gd name="csX1" fmla="*/ 3613199 w 7229139"/>
+                <a:gd name="csY1" fmla="*/ -1399 h 6228677"/>
+                <a:gd name="csX2" fmla="*/ 7227768 w 7229139"/>
+                <a:gd name="csY2" fmla="*/ 3112940 h 6228677"/>
+                <a:gd name="csX3" fmla="*/ 3613199 w 7229139"/>
+                <a:gd name="csY3" fmla="*/ 6227279 h 6228677"/>
+                <a:gd name="csX4" fmla="*/ -1371 w 7229139"/>
+                <a:gd name="csY4" fmla="*/ 3112940 h 6228677"/>
+              </a:gdLst>
+              <a:ahLst/>
+              <a:cxnLst>
+                <a:cxn ang="0">
+                  <a:pos x="csX0" y="csY0"/>
+                </a:cxn>
+                <a:cxn ang="0">
+                  <a:pos x="csX1" y="csY1"/>
+                </a:cxn>
+                <a:cxn ang="0">
+                  <a:pos x="csX2" y="csY2"/>
+                </a:cxn>
+                <a:cxn ang="0">
+                  <a:pos x="csX3" y="csY3"/>
+                </a:cxn>
+                <a:cxn ang="0">
+                  <a:pos x="csX4" y="csY4"/>
+                </a:cxn>
+              </a:cxnLst>
+              <a:rect l="l" t="t" r="r" b="b"/>
+              <a:pathLst>
+                <a:path w="7229139" h="6228677">
+                  <a:moveTo>
+                    <a:pt x="-1371" y="3112940"/>
+                  </a:moveTo>
+                  <a:cubicBezTo>
+                    <a:pt x="-1371" y="1392953"/>
+                    <a:pt x="1616955" y="-1399"/>
+                    <a:pt x="3613199" y="-1399"/>
+                  </a:cubicBezTo>
+                  <a:cubicBezTo>
+                    <a:pt x="5609441" y="-1399"/>
+                    <a:pt x="7227768" y="1392953"/>
+                    <a:pt x="7227768" y="3112940"/>
+                  </a:cubicBezTo>
+                  <a:cubicBezTo>
+                    <a:pt x="7227768" y="4832927"/>
+                    <a:pt x="5609441" y="6227279"/>
+                    <a:pt x="3613199" y="6227279"/>
+                  </a:cubicBezTo>
+                  <a:cubicBezTo>
+                    <a:pt x="1616955" y="6227279"/>
+                    <a:pt x="-1371" y="4832927"/>
+                    <a:pt x="-1371" y="3112940"/>
+                  </a:cubicBezTo>
+                  <a:close/>
+                </a:path>
+              </a:pathLst>
+            </a:custGeom>
+            <a:solidFill>
+              <a:schemeClr val="accent5">
+                <a:lumMod val="50000"/>
+                <a:alpha val="15000"/>
+              </a:schemeClr>
+            </a:solidFill>
+            <a:ln w="8067" cap="flat">
+              <a:noFill/>
+              <a:prstDash val="solid"/>
+              <a:miter/>
+            </a:ln>
+          </p:spPr>
+          <p:txBody>
+            <a:bodyPr/>
+            <a:lstStyle/>
+            <a:p>
+              <a:endParaRPr lang="en-US"/>
+            </a:p>
+          </p:txBody>
+        </p:sp>
+        <p:pic>
+          <p:nvPicPr>
+            <p:cNvPr id="71" name="Graphic 70" descr="Handshake outline">
+              <a:extLst>
+                <a:ext uri="{FF2B5EF4-FFF2-40B4-BE49-F238E27FC236}">
+                  <a16:creationId xmlns:a16="http://schemas.microsoft.com/office/drawing/2014/main" id="{AA291953-9BBF-33E0-DF83-D81DD48CB98E}"/>
+                </a:ext>
+              </a:extLst>
+            </p:cNvPr>
+            <p:cNvPicPr>
+              <a:picLocks noChangeAspect="1"/>
+            </p:cNvPicPr>
+            <p:nvPr/>
+          </p:nvPicPr>
+          <p:blipFill>
+            <a:blip>
+              <a:extLst>
+                <a:ext uri="{96DAC541-7B7A-43D3-8B79-37D633B846F1}">
+                  <asvg:svgBlip xmlns:asvg="http://schemas.microsoft.com/office/drawing/2016/SVG/main" r:embed="rId2"/>
+                </a:ext>
+              </a:extLst>
+            </a:blip>
+            <a:stretch>
+              <a:fillRect/>
+            </a:stretch>
+          </p:blipFill>
+          <p:spPr>
+            <a:xfrm>
+              <a:off x="5367075" y="914400"/>
+              <a:ext cx="5029200" cy="5029200"/>
+            </a:xfrm>
+            <a:prstGeom prst="rect">
+              <a:avLst/>
+            </a:prstGeom>
+            <a:effectLst>
+              <a:outerShdw blurRad="50800" dist="127000" dir="2700000" algn="tl" rotWithShape="0">
+                <a:schemeClr val="accent1">
+                  <a:alpha val="40000"/>
+                </a:schemeClr>
+              </a:outerShdw>
+            </a:effectLst>
+          </p:spPr>
+        </p:pic>
+      </p:grpSp>
     </p:spTree>
     <p:extLst>
       <p:ext uri="{BB962C8B-B14F-4D97-AF65-F5344CB8AC3E}">
@@ -15012,245 +15033,266 @@
           <a:chExt cx="0" cy="0"/>
         </a:xfrm>
       </p:grpSpPr>
-      <p:sp>
-        <p:nvSpPr>
-          <p:cNvPr id="2" name="Freeform: Shape 1">
+      <p:grpSp>
+        <p:nvGrpSpPr>
+          <p:cNvPr id="3" name="Group 2">
             <a:extLst>
               <a:ext uri="{FF2B5EF4-FFF2-40B4-BE49-F238E27FC236}">
-                <a16:creationId xmlns:a16="http://schemas.microsoft.com/office/drawing/2014/main" id="{2059E4C9-AE06-C2EC-EE01-65CAD14BDA93}"/>
+                <a16:creationId xmlns:a16="http://schemas.microsoft.com/office/drawing/2014/main" id="{36527995-6817-3479-3DFD-73E5C1B25655}"/>
               </a:ext>
             </a:extLst>
           </p:cNvPr>
-          <p:cNvSpPr/>
+          <p:cNvGrpSpPr/>
           <p:nvPr/>
-        </p:nvSpPr>
-        <p:spPr>
-          <a:xfrm>
-            <a:off x="3003618" y="552917"/>
-            <a:ext cx="7229138" cy="6228674"/>
-          </a:xfrm>
-          <a:custGeom>
-            <a:avLst/>
-            <a:gdLst>
-              <a:gd name="csX0" fmla="*/ -1 w 7229138"/>
-              <a:gd name="csY0" fmla="*/ 3114376 h 6228674"/>
-              <a:gd name="csX1" fmla="*/ 3614568 w 7229138"/>
-              <a:gd name="csY1" fmla="*/ 40 h 6228674"/>
-              <a:gd name="csX2" fmla="*/ 7229137 w 7229138"/>
-              <a:gd name="csY2" fmla="*/ 3114376 h 6228674"/>
-              <a:gd name="csX3" fmla="*/ 3614568 w 7229138"/>
-              <a:gd name="csY3" fmla="*/ 6228715 h 6228674"/>
-              <a:gd name="csX4" fmla="*/ -1 w 7229138"/>
-              <a:gd name="csY4" fmla="*/ 3114376 h 6228674"/>
-            </a:gdLst>
-            <a:ahLst/>
-            <a:cxnLst>
-              <a:cxn ang="0">
-                <a:pos x="csX0" y="csY0"/>
-              </a:cxn>
-              <a:cxn ang="0">
-                <a:pos x="csX1" y="csY1"/>
-              </a:cxn>
-              <a:cxn ang="0">
-                <a:pos x="csX2" y="csY2"/>
-              </a:cxn>
-              <a:cxn ang="0">
-                <a:pos x="csX3" y="csY3"/>
-              </a:cxn>
-              <a:cxn ang="0">
-                <a:pos x="csX4" y="csY4"/>
-              </a:cxn>
-            </a:cxnLst>
-            <a:rect l="l" t="t" r="r" b="b"/>
-            <a:pathLst>
-              <a:path w="7229138" h="6228674">
-                <a:moveTo>
-                  <a:pt x="-1" y="3114376"/>
-                </a:moveTo>
-                <a:cubicBezTo>
-                  <a:pt x="-1" y="1394373"/>
-                  <a:pt x="1618301" y="40"/>
-                  <a:pt x="3614568" y="40"/>
-                </a:cubicBezTo>
-                <a:cubicBezTo>
-                  <a:pt x="5610843" y="40"/>
-                  <a:pt x="7229137" y="1394373"/>
-                  <a:pt x="7229137" y="3114376"/>
-                </a:cubicBezTo>
-                <a:cubicBezTo>
-                  <a:pt x="7229137" y="4834378"/>
-                  <a:pt x="5610843" y="6228715"/>
-                  <a:pt x="3614568" y="6228715"/>
-                </a:cubicBezTo>
-                <a:cubicBezTo>
-                  <a:pt x="1618301" y="6228715"/>
-                  <a:pt x="-1" y="4834378"/>
-                  <a:pt x="-1" y="3114376"/>
-                </a:cubicBezTo>
-                <a:close/>
-              </a:path>
-            </a:pathLst>
-          </a:custGeom>
-          <a:solidFill>
-            <a:srgbClr val="4472C4">
-              <a:alpha val="15000"/>
-            </a:srgbClr>
-          </a:solidFill>
-          <a:ln w="8067" cap="flat">
-            <a:noFill/>
-            <a:prstDash val="solid"/>
-            <a:miter/>
-          </a:ln>
-        </p:spPr>
-        <p:txBody>
-          <a:bodyPr/>
-          <a:lstStyle/>
-          <a:p>
-            <a:endParaRPr lang="en-US"/>
-          </a:p>
-        </p:txBody>
-      </p:sp>
-      <p:sp>
-        <p:nvSpPr>
-          <p:cNvPr id="9" name="Freeform: Shape 8">
-            <a:extLst>
-              <a:ext uri="{FF2B5EF4-FFF2-40B4-BE49-F238E27FC236}">
-                <a16:creationId xmlns:a16="http://schemas.microsoft.com/office/drawing/2014/main" id="{DF82AC9D-6D4C-795E-455F-E89F2575BEEF}"/>
-              </a:ext>
-            </a:extLst>
-          </p:cNvPr>
-          <p:cNvSpPr/>
-          <p:nvPr/>
-        </p:nvSpPr>
-        <p:spPr>
+        </p:nvGrpSpPr>
+        <p:grpSpPr>
           <a:xfrm>
             <a:off x="3003618" y="72185"/>
-            <a:ext cx="7229139" cy="6228677"/>
+            <a:ext cx="7229139" cy="6709406"/>
+            <a:chOff x="3003618" y="72185"/>
+            <a:chExt cx="7229139" cy="6709406"/>
           </a:xfrm>
-          <a:custGeom>
-            <a:avLst/>
-            <a:gdLst>
-              <a:gd name="csX0" fmla="*/ -1371 w 7229139"/>
-              <a:gd name="csY0" fmla="*/ 3112940 h 6228677"/>
-              <a:gd name="csX1" fmla="*/ 3613199 w 7229139"/>
-              <a:gd name="csY1" fmla="*/ -1399 h 6228677"/>
-              <a:gd name="csX2" fmla="*/ 7227768 w 7229139"/>
-              <a:gd name="csY2" fmla="*/ 3112940 h 6228677"/>
-              <a:gd name="csX3" fmla="*/ 3613199 w 7229139"/>
-              <a:gd name="csY3" fmla="*/ 6227279 h 6228677"/>
-              <a:gd name="csX4" fmla="*/ -1371 w 7229139"/>
-              <a:gd name="csY4" fmla="*/ 3112940 h 6228677"/>
-            </a:gdLst>
-            <a:ahLst/>
-            <a:cxnLst>
-              <a:cxn ang="0">
-                <a:pos x="csX0" y="csY0"/>
-              </a:cxn>
-              <a:cxn ang="0">
-                <a:pos x="csX1" y="csY1"/>
-              </a:cxn>
-              <a:cxn ang="0">
-                <a:pos x="csX2" y="csY2"/>
-              </a:cxn>
-              <a:cxn ang="0">
-                <a:pos x="csX3" y="csY3"/>
-              </a:cxn>
-              <a:cxn ang="0">
-                <a:pos x="csX4" y="csY4"/>
-              </a:cxn>
-            </a:cxnLst>
-            <a:rect l="l" t="t" r="r" b="b"/>
-            <a:pathLst>
-              <a:path w="7229139" h="6228677">
-                <a:moveTo>
-                  <a:pt x="-1371" y="3112940"/>
-                </a:moveTo>
-                <a:cubicBezTo>
-                  <a:pt x="-1371" y="1392953"/>
-                  <a:pt x="1616955" y="-1399"/>
-                  <a:pt x="3613199" y="-1399"/>
-                </a:cubicBezTo>
-                <a:cubicBezTo>
-                  <a:pt x="5609441" y="-1399"/>
-                  <a:pt x="7227768" y="1392953"/>
-                  <a:pt x="7227768" y="3112940"/>
-                </a:cubicBezTo>
-                <a:cubicBezTo>
-                  <a:pt x="7227768" y="4832927"/>
-                  <a:pt x="5609441" y="6227279"/>
-                  <a:pt x="3613199" y="6227279"/>
-                </a:cubicBezTo>
-                <a:cubicBezTo>
-                  <a:pt x="1616955" y="6227279"/>
-                  <a:pt x="-1371" y="4832927"/>
-                  <a:pt x="-1371" y="3112940"/>
-                </a:cubicBezTo>
-                <a:close/>
-              </a:path>
-            </a:pathLst>
-          </a:custGeom>
-          <a:solidFill>
-            <a:srgbClr val="4472C4">
-              <a:alpha val="15000"/>
-            </a:srgbClr>
-          </a:solidFill>
-          <a:ln w="8067" cap="flat">
-            <a:noFill/>
-            <a:prstDash val="solid"/>
-            <a:miter/>
-          </a:ln>
-        </p:spPr>
-        <p:txBody>
-          <a:bodyPr/>
-          <a:lstStyle/>
-          <a:p>
-            <a:endParaRPr lang="en-US"/>
-          </a:p>
-        </p:txBody>
-      </p:sp>
-      <p:pic>
-        <p:nvPicPr>
-          <p:cNvPr id="11" name="Graphic 10" descr="Money outline">
-            <a:extLst>
-              <a:ext uri="{FF2B5EF4-FFF2-40B4-BE49-F238E27FC236}">
-                <a16:creationId xmlns:a16="http://schemas.microsoft.com/office/drawing/2014/main" id="{A307EB66-7D70-3B84-3775-A8A661264B58}"/>
-              </a:ext>
-            </a:extLst>
-          </p:cNvPr>
-          <p:cNvPicPr>
-            <a:picLocks noChangeAspect="1"/>
-          </p:cNvPicPr>
-          <p:nvPr/>
-        </p:nvPicPr>
-        <p:blipFill>
-          <a:blip>
-            <a:extLst>
-              <a:ext uri="{96DAC541-7B7A-43D3-8B79-37D633B846F1}">
-                <asvg:svgBlip xmlns:asvg="http://schemas.microsoft.com/office/drawing/2016/SVG/main" r:embed="rId2"/>
-              </a:ext>
-            </a:extLst>
-          </a:blip>
-          <a:stretch>
-            <a:fillRect/>
-          </a:stretch>
-        </p:blipFill>
-        <p:spPr>
-          <a:xfrm>
-            <a:off x="4103587" y="914400"/>
-            <a:ext cx="5029200" cy="5029200"/>
-          </a:xfrm>
-          <a:prstGeom prst="rect">
-            <a:avLst/>
-          </a:prstGeom>
-          <a:effectLst>
-            <a:outerShdw blurRad="50800" dist="127000" dir="2700000" algn="tl" rotWithShape="0">
-              <a:schemeClr val="accent1">
-                <a:alpha val="40000"/>
-              </a:schemeClr>
-            </a:outerShdw>
-          </a:effectLst>
-        </p:spPr>
-      </p:pic>
+        </p:grpSpPr>
+        <p:sp>
+          <p:nvSpPr>
+            <p:cNvPr id="2" name="Freeform: Shape 1">
+              <a:extLst>
+                <a:ext uri="{FF2B5EF4-FFF2-40B4-BE49-F238E27FC236}">
+                  <a16:creationId xmlns:a16="http://schemas.microsoft.com/office/drawing/2014/main" id="{2059E4C9-AE06-C2EC-EE01-65CAD14BDA93}"/>
+                </a:ext>
+              </a:extLst>
+            </p:cNvPr>
+            <p:cNvSpPr/>
+            <p:nvPr/>
+          </p:nvSpPr>
+          <p:spPr>
+            <a:xfrm>
+              <a:off x="3003618" y="552917"/>
+              <a:ext cx="7229138" cy="6228674"/>
+            </a:xfrm>
+            <a:custGeom>
+              <a:avLst/>
+              <a:gdLst>
+                <a:gd name="csX0" fmla="*/ -1 w 7229138"/>
+                <a:gd name="csY0" fmla="*/ 3114376 h 6228674"/>
+                <a:gd name="csX1" fmla="*/ 3614568 w 7229138"/>
+                <a:gd name="csY1" fmla="*/ 40 h 6228674"/>
+                <a:gd name="csX2" fmla="*/ 7229137 w 7229138"/>
+                <a:gd name="csY2" fmla="*/ 3114376 h 6228674"/>
+                <a:gd name="csX3" fmla="*/ 3614568 w 7229138"/>
+                <a:gd name="csY3" fmla="*/ 6228715 h 6228674"/>
+                <a:gd name="csX4" fmla="*/ -1 w 7229138"/>
+                <a:gd name="csY4" fmla="*/ 3114376 h 6228674"/>
+              </a:gdLst>
+              <a:ahLst/>
+              <a:cxnLst>
+                <a:cxn ang="0">
+                  <a:pos x="csX0" y="csY0"/>
+                </a:cxn>
+                <a:cxn ang="0">
+                  <a:pos x="csX1" y="csY1"/>
+                </a:cxn>
+                <a:cxn ang="0">
+                  <a:pos x="csX2" y="csY2"/>
+                </a:cxn>
+                <a:cxn ang="0">
+                  <a:pos x="csX3" y="csY3"/>
+                </a:cxn>
+                <a:cxn ang="0">
+                  <a:pos x="csX4" y="csY4"/>
+                </a:cxn>
+              </a:cxnLst>
+              <a:rect l="l" t="t" r="r" b="b"/>
+              <a:pathLst>
+                <a:path w="7229138" h="6228674">
+                  <a:moveTo>
+                    <a:pt x="-1" y="3114376"/>
+                  </a:moveTo>
+                  <a:cubicBezTo>
+                    <a:pt x="-1" y="1394373"/>
+                    <a:pt x="1618301" y="40"/>
+                    <a:pt x="3614568" y="40"/>
+                  </a:cubicBezTo>
+                  <a:cubicBezTo>
+                    <a:pt x="5610843" y="40"/>
+                    <a:pt x="7229137" y="1394373"/>
+                    <a:pt x="7229137" y="3114376"/>
+                  </a:cubicBezTo>
+                  <a:cubicBezTo>
+                    <a:pt x="7229137" y="4834378"/>
+                    <a:pt x="5610843" y="6228715"/>
+                    <a:pt x="3614568" y="6228715"/>
+                  </a:cubicBezTo>
+                  <a:cubicBezTo>
+                    <a:pt x="1618301" y="6228715"/>
+                    <a:pt x="-1" y="4834378"/>
+                    <a:pt x="-1" y="3114376"/>
+                  </a:cubicBezTo>
+                  <a:close/>
+                </a:path>
+              </a:pathLst>
+            </a:custGeom>
+            <a:solidFill>
+              <a:srgbClr val="4472C4">
+                <a:alpha val="15000"/>
+              </a:srgbClr>
+            </a:solidFill>
+            <a:ln w="8067" cap="flat">
+              <a:noFill/>
+              <a:prstDash val="solid"/>
+              <a:miter/>
+            </a:ln>
+          </p:spPr>
+          <p:txBody>
+            <a:bodyPr/>
+            <a:lstStyle/>
+            <a:p>
+              <a:endParaRPr lang="en-US"/>
+            </a:p>
+          </p:txBody>
+        </p:sp>
+        <p:sp>
+          <p:nvSpPr>
+            <p:cNvPr id="9" name="Freeform: Shape 8">
+              <a:extLst>
+                <a:ext uri="{FF2B5EF4-FFF2-40B4-BE49-F238E27FC236}">
+                  <a16:creationId xmlns:a16="http://schemas.microsoft.com/office/drawing/2014/main" id="{DF82AC9D-6D4C-795E-455F-E89F2575BEEF}"/>
+                </a:ext>
+              </a:extLst>
+            </p:cNvPr>
+            <p:cNvSpPr/>
+            <p:nvPr/>
+          </p:nvSpPr>
+          <p:spPr>
+            <a:xfrm>
+              <a:off x="3003618" y="72185"/>
+              <a:ext cx="7229139" cy="6228677"/>
+            </a:xfrm>
+            <a:custGeom>
+              <a:avLst/>
+              <a:gdLst>
+                <a:gd name="csX0" fmla="*/ -1371 w 7229139"/>
+                <a:gd name="csY0" fmla="*/ 3112940 h 6228677"/>
+                <a:gd name="csX1" fmla="*/ 3613199 w 7229139"/>
+                <a:gd name="csY1" fmla="*/ -1399 h 6228677"/>
+                <a:gd name="csX2" fmla="*/ 7227768 w 7229139"/>
+                <a:gd name="csY2" fmla="*/ 3112940 h 6228677"/>
+                <a:gd name="csX3" fmla="*/ 3613199 w 7229139"/>
+                <a:gd name="csY3" fmla="*/ 6227279 h 6228677"/>
+                <a:gd name="csX4" fmla="*/ -1371 w 7229139"/>
+                <a:gd name="csY4" fmla="*/ 3112940 h 6228677"/>
+              </a:gdLst>
+              <a:ahLst/>
+              <a:cxnLst>
+                <a:cxn ang="0">
+                  <a:pos x="csX0" y="csY0"/>
+                </a:cxn>
+                <a:cxn ang="0">
+                  <a:pos x="csX1" y="csY1"/>
+                </a:cxn>
+                <a:cxn ang="0">
+                  <a:pos x="csX2" y="csY2"/>
+                </a:cxn>
+                <a:cxn ang="0">
+                  <a:pos x="csX3" y="csY3"/>
+                </a:cxn>
+                <a:cxn ang="0">
+                  <a:pos x="csX4" y="csY4"/>
+                </a:cxn>
+              </a:cxnLst>
+              <a:rect l="l" t="t" r="r" b="b"/>
+              <a:pathLst>
+                <a:path w="7229139" h="6228677">
+                  <a:moveTo>
+                    <a:pt x="-1371" y="3112940"/>
+                  </a:moveTo>
+                  <a:cubicBezTo>
+                    <a:pt x="-1371" y="1392953"/>
+                    <a:pt x="1616955" y="-1399"/>
+                    <a:pt x="3613199" y="-1399"/>
+                  </a:cubicBezTo>
+                  <a:cubicBezTo>
+                    <a:pt x="5609441" y="-1399"/>
+                    <a:pt x="7227768" y="1392953"/>
+                    <a:pt x="7227768" y="3112940"/>
+                  </a:cubicBezTo>
+                  <a:cubicBezTo>
+                    <a:pt x="7227768" y="4832927"/>
+                    <a:pt x="5609441" y="6227279"/>
+                    <a:pt x="3613199" y="6227279"/>
+                  </a:cubicBezTo>
+                  <a:cubicBezTo>
+                    <a:pt x="1616955" y="6227279"/>
+                    <a:pt x="-1371" y="4832927"/>
+                    <a:pt x="-1371" y="3112940"/>
+                  </a:cubicBezTo>
+                  <a:close/>
+                </a:path>
+              </a:pathLst>
+            </a:custGeom>
+            <a:solidFill>
+              <a:srgbClr val="4472C4">
+                <a:alpha val="15000"/>
+              </a:srgbClr>
+            </a:solidFill>
+            <a:ln w="8067" cap="flat">
+              <a:noFill/>
+              <a:prstDash val="solid"/>
+              <a:miter/>
+            </a:ln>
+          </p:spPr>
+          <p:txBody>
+            <a:bodyPr/>
+            <a:lstStyle/>
+            <a:p>
+              <a:endParaRPr lang="en-US"/>
+            </a:p>
+          </p:txBody>
+        </p:sp>
+        <p:pic>
+          <p:nvPicPr>
+            <p:cNvPr id="11" name="Graphic 10" descr="Money outline">
+              <a:extLst>
+                <a:ext uri="{FF2B5EF4-FFF2-40B4-BE49-F238E27FC236}">
+                  <a16:creationId xmlns:a16="http://schemas.microsoft.com/office/drawing/2014/main" id="{A307EB66-7D70-3B84-3775-A8A661264B58}"/>
+                </a:ext>
+              </a:extLst>
+            </p:cNvPr>
+            <p:cNvPicPr>
+              <a:picLocks noChangeAspect="1"/>
+            </p:cNvPicPr>
+            <p:nvPr/>
+          </p:nvPicPr>
+          <p:blipFill>
+            <a:blip>
+              <a:extLst>
+                <a:ext uri="{96DAC541-7B7A-43D3-8B79-37D633B846F1}">
+                  <asvg:svgBlip xmlns:asvg="http://schemas.microsoft.com/office/drawing/2016/SVG/main" r:embed="rId2"/>
+                </a:ext>
+              </a:extLst>
+            </a:blip>
+            <a:stretch>
+              <a:fillRect/>
+            </a:stretch>
+          </p:blipFill>
+          <p:spPr>
+            <a:xfrm>
+              <a:off x="4103587" y="914400"/>
+              <a:ext cx="5029200" cy="5029200"/>
+            </a:xfrm>
+            <a:prstGeom prst="rect">
+              <a:avLst/>
+            </a:prstGeom>
+            <a:effectLst>
+              <a:outerShdw blurRad="50800" dist="127000" dir="2700000" algn="tl" rotWithShape="0">
+                <a:schemeClr val="accent1">
+                  <a:alpha val="40000"/>
+                </a:schemeClr>
+              </a:outerShdw>
+            </a:effectLst>
+          </p:spPr>
+        </p:pic>
+      </p:grpSp>
     </p:spTree>
     <p:extLst>
       <p:ext uri="{BB962C8B-B14F-4D97-AF65-F5344CB8AC3E}">
@@ -15287,245 +15329,266 @@
           <a:chExt cx="0" cy="0"/>
         </a:xfrm>
       </p:grpSpPr>
-      <p:sp>
-        <p:nvSpPr>
-          <p:cNvPr id="2" name="Freeform: Shape 1">
+      <p:grpSp>
+        <p:nvGrpSpPr>
+          <p:cNvPr id="3" name="Group 2">
             <a:extLst>
               <a:ext uri="{FF2B5EF4-FFF2-40B4-BE49-F238E27FC236}">
-                <a16:creationId xmlns:a16="http://schemas.microsoft.com/office/drawing/2014/main" id="{41D67997-62AD-7FDF-6B3F-99C4F957D144}"/>
+                <a16:creationId xmlns:a16="http://schemas.microsoft.com/office/drawing/2014/main" id="{CF709B76-4BD0-A46C-5509-E65F01A76CEF}"/>
               </a:ext>
             </a:extLst>
           </p:cNvPr>
-          <p:cNvSpPr/>
+          <p:cNvGrpSpPr/>
           <p:nvPr/>
-        </p:nvSpPr>
-        <p:spPr>
-          <a:xfrm>
-            <a:off x="3003618" y="552917"/>
-            <a:ext cx="7229138" cy="6228674"/>
-          </a:xfrm>
-          <a:custGeom>
-            <a:avLst/>
-            <a:gdLst>
-              <a:gd name="csX0" fmla="*/ -1 w 7229138"/>
-              <a:gd name="csY0" fmla="*/ 3114376 h 6228674"/>
-              <a:gd name="csX1" fmla="*/ 3614568 w 7229138"/>
-              <a:gd name="csY1" fmla="*/ 40 h 6228674"/>
-              <a:gd name="csX2" fmla="*/ 7229137 w 7229138"/>
-              <a:gd name="csY2" fmla="*/ 3114376 h 6228674"/>
-              <a:gd name="csX3" fmla="*/ 3614568 w 7229138"/>
-              <a:gd name="csY3" fmla="*/ 6228715 h 6228674"/>
-              <a:gd name="csX4" fmla="*/ -1 w 7229138"/>
-              <a:gd name="csY4" fmla="*/ 3114376 h 6228674"/>
-            </a:gdLst>
-            <a:ahLst/>
-            <a:cxnLst>
-              <a:cxn ang="0">
-                <a:pos x="csX0" y="csY0"/>
-              </a:cxn>
-              <a:cxn ang="0">
-                <a:pos x="csX1" y="csY1"/>
-              </a:cxn>
-              <a:cxn ang="0">
-                <a:pos x="csX2" y="csY2"/>
-              </a:cxn>
-              <a:cxn ang="0">
-                <a:pos x="csX3" y="csY3"/>
-              </a:cxn>
-              <a:cxn ang="0">
-                <a:pos x="csX4" y="csY4"/>
-              </a:cxn>
-            </a:cxnLst>
-            <a:rect l="l" t="t" r="r" b="b"/>
-            <a:pathLst>
-              <a:path w="7229138" h="6228674">
-                <a:moveTo>
-                  <a:pt x="-1" y="3114376"/>
-                </a:moveTo>
-                <a:cubicBezTo>
-                  <a:pt x="-1" y="1394373"/>
-                  <a:pt x="1618301" y="40"/>
-                  <a:pt x="3614568" y="40"/>
-                </a:cubicBezTo>
-                <a:cubicBezTo>
-                  <a:pt x="5610843" y="40"/>
-                  <a:pt x="7229137" y="1394373"/>
-                  <a:pt x="7229137" y="3114376"/>
-                </a:cubicBezTo>
-                <a:cubicBezTo>
-                  <a:pt x="7229137" y="4834378"/>
-                  <a:pt x="5610843" y="6228715"/>
-                  <a:pt x="3614568" y="6228715"/>
-                </a:cubicBezTo>
-                <a:cubicBezTo>
-                  <a:pt x="1618301" y="6228715"/>
-                  <a:pt x="-1" y="4834378"/>
-                  <a:pt x="-1" y="3114376"/>
-                </a:cubicBezTo>
-                <a:close/>
-              </a:path>
-            </a:pathLst>
-          </a:custGeom>
-          <a:solidFill>
-            <a:srgbClr val="4472C4">
-              <a:alpha val="15000"/>
-            </a:srgbClr>
-          </a:solidFill>
-          <a:ln w="8067" cap="flat">
-            <a:noFill/>
-            <a:prstDash val="solid"/>
-            <a:miter/>
-          </a:ln>
-        </p:spPr>
-        <p:txBody>
-          <a:bodyPr/>
-          <a:lstStyle/>
-          <a:p>
-            <a:endParaRPr lang="en-US"/>
-          </a:p>
-        </p:txBody>
-      </p:sp>
-      <p:sp>
-        <p:nvSpPr>
-          <p:cNvPr id="9" name="Freeform: Shape 8">
-            <a:extLst>
-              <a:ext uri="{FF2B5EF4-FFF2-40B4-BE49-F238E27FC236}">
-                <a16:creationId xmlns:a16="http://schemas.microsoft.com/office/drawing/2014/main" id="{19051373-DB3B-F7D0-7E5A-6D3BDD94CD03}"/>
-              </a:ext>
-            </a:extLst>
-          </p:cNvPr>
-          <p:cNvSpPr/>
-          <p:nvPr/>
-        </p:nvSpPr>
-        <p:spPr>
+        </p:nvGrpSpPr>
+        <p:grpSpPr>
           <a:xfrm>
             <a:off x="3003618" y="72185"/>
-            <a:ext cx="7229139" cy="6228677"/>
+            <a:ext cx="7229139" cy="6709406"/>
+            <a:chOff x="3003618" y="72185"/>
+            <a:chExt cx="7229139" cy="6709406"/>
           </a:xfrm>
-          <a:custGeom>
-            <a:avLst/>
-            <a:gdLst>
-              <a:gd name="csX0" fmla="*/ -1371 w 7229139"/>
-              <a:gd name="csY0" fmla="*/ 3112940 h 6228677"/>
-              <a:gd name="csX1" fmla="*/ 3613199 w 7229139"/>
-              <a:gd name="csY1" fmla="*/ -1399 h 6228677"/>
-              <a:gd name="csX2" fmla="*/ 7227768 w 7229139"/>
-              <a:gd name="csY2" fmla="*/ 3112940 h 6228677"/>
-              <a:gd name="csX3" fmla="*/ 3613199 w 7229139"/>
-              <a:gd name="csY3" fmla="*/ 6227279 h 6228677"/>
-              <a:gd name="csX4" fmla="*/ -1371 w 7229139"/>
-              <a:gd name="csY4" fmla="*/ 3112940 h 6228677"/>
-            </a:gdLst>
-            <a:ahLst/>
-            <a:cxnLst>
-              <a:cxn ang="0">
-                <a:pos x="csX0" y="csY0"/>
-              </a:cxn>
-              <a:cxn ang="0">
-                <a:pos x="csX1" y="csY1"/>
-              </a:cxn>
-              <a:cxn ang="0">
-                <a:pos x="csX2" y="csY2"/>
-              </a:cxn>
-              <a:cxn ang="0">
-                <a:pos x="csX3" y="csY3"/>
-              </a:cxn>
-              <a:cxn ang="0">
-                <a:pos x="csX4" y="csY4"/>
-              </a:cxn>
-            </a:cxnLst>
-            <a:rect l="l" t="t" r="r" b="b"/>
-            <a:pathLst>
-              <a:path w="7229139" h="6228677">
-                <a:moveTo>
-                  <a:pt x="-1371" y="3112940"/>
-                </a:moveTo>
-                <a:cubicBezTo>
-                  <a:pt x="-1371" y="1392953"/>
-                  <a:pt x="1616955" y="-1399"/>
-                  <a:pt x="3613199" y="-1399"/>
-                </a:cubicBezTo>
-                <a:cubicBezTo>
-                  <a:pt x="5609441" y="-1399"/>
-                  <a:pt x="7227768" y="1392953"/>
-                  <a:pt x="7227768" y="3112940"/>
-                </a:cubicBezTo>
-                <a:cubicBezTo>
-                  <a:pt x="7227768" y="4832927"/>
-                  <a:pt x="5609441" y="6227279"/>
-                  <a:pt x="3613199" y="6227279"/>
-                </a:cubicBezTo>
-                <a:cubicBezTo>
-                  <a:pt x="1616955" y="6227279"/>
-                  <a:pt x="-1371" y="4832927"/>
-                  <a:pt x="-1371" y="3112940"/>
-                </a:cubicBezTo>
-                <a:close/>
-              </a:path>
-            </a:pathLst>
-          </a:custGeom>
-          <a:solidFill>
-            <a:srgbClr val="4472C4">
-              <a:alpha val="15000"/>
-            </a:srgbClr>
-          </a:solidFill>
-          <a:ln w="8067" cap="flat">
-            <a:noFill/>
-            <a:prstDash val="solid"/>
-            <a:miter/>
-          </a:ln>
-        </p:spPr>
-        <p:txBody>
-          <a:bodyPr/>
-          <a:lstStyle/>
-          <a:p>
-            <a:endParaRPr lang="en-US"/>
-          </a:p>
-        </p:txBody>
-      </p:sp>
-      <p:pic>
-        <p:nvPicPr>
-          <p:cNvPr id="53" name="Graphic 52" descr="Hierarchy outline">
-            <a:extLst>
-              <a:ext uri="{FF2B5EF4-FFF2-40B4-BE49-F238E27FC236}">
-                <a16:creationId xmlns:a16="http://schemas.microsoft.com/office/drawing/2014/main" id="{B4FA1865-06E0-410E-0884-7ED3E9039DA3}"/>
-              </a:ext>
-            </a:extLst>
-          </p:cNvPr>
-          <p:cNvPicPr>
-            <a:picLocks noChangeAspect="1"/>
-          </p:cNvPicPr>
-          <p:nvPr/>
-        </p:nvPicPr>
-        <p:blipFill>
-          <a:blip>
-            <a:extLst>
-              <a:ext uri="{96DAC541-7B7A-43D3-8B79-37D633B846F1}">
-                <asvg:svgBlip xmlns:asvg="http://schemas.microsoft.com/office/drawing/2016/SVG/main" r:embed="rId2"/>
-              </a:ext>
-            </a:extLst>
-          </a:blip>
-          <a:stretch>
-            <a:fillRect/>
-          </a:stretch>
-        </p:blipFill>
-        <p:spPr>
-          <a:xfrm>
-            <a:off x="4103587" y="914400"/>
-            <a:ext cx="5029200" cy="5029200"/>
-          </a:xfrm>
-          <a:prstGeom prst="rect">
-            <a:avLst/>
-          </a:prstGeom>
-          <a:effectLst>
-            <a:outerShdw blurRad="50800" dist="127000" dir="2700000" algn="tl" rotWithShape="0">
-              <a:schemeClr val="accent1">
-                <a:alpha val="40000"/>
-              </a:schemeClr>
-            </a:outerShdw>
-          </a:effectLst>
-        </p:spPr>
-      </p:pic>
+        </p:grpSpPr>
+        <p:sp>
+          <p:nvSpPr>
+            <p:cNvPr id="2" name="Freeform: Shape 1">
+              <a:extLst>
+                <a:ext uri="{FF2B5EF4-FFF2-40B4-BE49-F238E27FC236}">
+                  <a16:creationId xmlns:a16="http://schemas.microsoft.com/office/drawing/2014/main" id="{41D67997-62AD-7FDF-6B3F-99C4F957D144}"/>
+                </a:ext>
+              </a:extLst>
+            </p:cNvPr>
+            <p:cNvSpPr/>
+            <p:nvPr/>
+          </p:nvSpPr>
+          <p:spPr>
+            <a:xfrm>
+              <a:off x="3003618" y="552917"/>
+              <a:ext cx="7229138" cy="6228674"/>
+            </a:xfrm>
+            <a:custGeom>
+              <a:avLst/>
+              <a:gdLst>
+                <a:gd name="csX0" fmla="*/ -1 w 7229138"/>
+                <a:gd name="csY0" fmla="*/ 3114376 h 6228674"/>
+                <a:gd name="csX1" fmla="*/ 3614568 w 7229138"/>
+                <a:gd name="csY1" fmla="*/ 40 h 6228674"/>
+                <a:gd name="csX2" fmla="*/ 7229137 w 7229138"/>
+                <a:gd name="csY2" fmla="*/ 3114376 h 6228674"/>
+                <a:gd name="csX3" fmla="*/ 3614568 w 7229138"/>
+                <a:gd name="csY3" fmla="*/ 6228715 h 6228674"/>
+                <a:gd name="csX4" fmla="*/ -1 w 7229138"/>
+                <a:gd name="csY4" fmla="*/ 3114376 h 6228674"/>
+              </a:gdLst>
+              <a:ahLst/>
+              <a:cxnLst>
+                <a:cxn ang="0">
+                  <a:pos x="csX0" y="csY0"/>
+                </a:cxn>
+                <a:cxn ang="0">
+                  <a:pos x="csX1" y="csY1"/>
+                </a:cxn>
+                <a:cxn ang="0">
+                  <a:pos x="csX2" y="csY2"/>
+                </a:cxn>
+                <a:cxn ang="0">
+                  <a:pos x="csX3" y="csY3"/>
+                </a:cxn>
+                <a:cxn ang="0">
+                  <a:pos x="csX4" y="csY4"/>
+                </a:cxn>
+              </a:cxnLst>
+              <a:rect l="l" t="t" r="r" b="b"/>
+              <a:pathLst>
+                <a:path w="7229138" h="6228674">
+                  <a:moveTo>
+                    <a:pt x="-1" y="3114376"/>
+                  </a:moveTo>
+                  <a:cubicBezTo>
+                    <a:pt x="-1" y="1394373"/>
+                    <a:pt x="1618301" y="40"/>
+                    <a:pt x="3614568" y="40"/>
+                  </a:cubicBezTo>
+                  <a:cubicBezTo>
+                    <a:pt x="5610843" y="40"/>
+                    <a:pt x="7229137" y="1394373"/>
+                    <a:pt x="7229137" y="3114376"/>
+                  </a:cubicBezTo>
+                  <a:cubicBezTo>
+                    <a:pt x="7229137" y="4834378"/>
+                    <a:pt x="5610843" y="6228715"/>
+                    <a:pt x="3614568" y="6228715"/>
+                  </a:cubicBezTo>
+                  <a:cubicBezTo>
+                    <a:pt x="1618301" y="6228715"/>
+                    <a:pt x="-1" y="4834378"/>
+                    <a:pt x="-1" y="3114376"/>
+                  </a:cubicBezTo>
+                  <a:close/>
+                </a:path>
+              </a:pathLst>
+            </a:custGeom>
+            <a:solidFill>
+              <a:srgbClr val="4472C4">
+                <a:alpha val="15000"/>
+              </a:srgbClr>
+            </a:solidFill>
+            <a:ln w="8067" cap="flat">
+              <a:noFill/>
+              <a:prstDash val="solid"/>
+              <a:miter/>
+            </a:ln>
+          </p:spPr>
+          <p:txBody>
+            <a:bodyPr/>
+            <a:lstStyle/>
+            <a:p>
+              <a:endParaRPr lang="en-US"/>
+            </a:p>
+          </p:txBody>
+        </p:sp>
+        <p:sp>
+          <p:nvSpPr>
+            <p:cNvPr id="9" name="Freeform: Shape 8">
+              <a:extLst>
+                <a:ext uri="{FF2B5EF4-FFF2-40B4-BE49-F238E27FC236}">
+                  <a16:creationId xmlns:a16="http://schemas.microsoft.com/office/drawing/2014/main" id="{19051373-DB3B-F7D0-7E5A-6D3BDD94CD03}"/>
+                </a:ext>
+              </a:extLst>
+            </p:cNvPr>
+            <p:cNvSpPr/>
+            <p:nvPr/>
+          </p:nvSpPr>
+          <p:spPr>
+            <a:xfrm>
+              <a:off x="3003618" y="72185"/>
+              <a:ext cx="7229139" cy="6228677"/>
+            </a:xfrm>
+            <a:custGeom>
+              <a:avLst/>
+              <a:gdLst>
+                <a:gd name="csX0" fmla="*/ -1371 w 7229139"/>
+                <a:gd name="csY0" fmla="*/ 3112940 h 6228677"/>
+                <a:gd name="csX1" fmla="*/ 3613199 w 7229139"/>
+                <a:gd name="csY1" fmla="*/ -1399 h 6228677"/>
+                <a:gd name="csX2" fmla="*/ 7227768 w 7229139"/>
+                <a:gd name="csY2" fmla="*/ 3112940 h 6228677"/>
+                <a:gd name="csX3" fmla="*/ 3613199 w 7229139"/>
+                <a:gd name="csY3" fmla="*/ 6227279 h 6228677"/>
+                <a:gd name="csX4" fmla="*/ -1371 w 7229139"/>
+                <a:gd name="csY4" fmla="*/ 3112940 h 6228677"/>
+              </a:gdLst>
+              <a:ahLst/>
+              <a:cxnLst>
+                <a:cxn ang="0">
+                  <a:pos x="csX0" y="csY0"/>
+                </a:cxn>
+                <a:cxn ang="0">
+                  <a:pos x="csX1" y="csY1"/>
+                </a:cxn>
+                <a:cxn ang="0">
+                  <a:pos x="csX2" y="csY2"/>
+                </a:cxn>
+                <a:cxn ang="0">
+                  <a:pos x="csX3" y="csY3"/>
+                </a:cxn>
+                <a:cxn ang="0">
+                  <a:pos x="csX4" y="csY4"/>
+                </a:cxn>
+              </a:cxnLst>
+              <a:rect l="l" t="t" r="r" b="b"/>
+              <a:pathLst>
+                <a:path w="7229139" h="6228677">
+                  <a:moveTo>
+                    <a:pt x="-1371" y="3112940"/>
+                  </a:moveTo>
+                  <a:cubicBezTo>
+                    <a:pt x="-1371" y="1392953"/>
+                    <a:pt x="1616955" y="-1399"/>
+                    <a:pt x="3613199" y="-1399"/>
+                  </a:cubicBezTo>
+                  <a:cubicBezTo>
+                    <a:pt x="5609441" y="-1399"/>
+                    <a:pt x="7227768" y="1392953"/>
+                    <a:pt x="7227768" y="3112940"/>
+                  </a:cubicBezTo>
+                  <a:cubicBezTo>
+                    <a:pt x="7227768" y="4832927"/>
+                    <a:pt x="5609441" y="6227279"/>
+                    <a:pt x="3613199" y="6227279"/>
+                  </a:cubicBezTo>
+                  <a:cubicBezTo>
+                    <a:pt x="1616955" y="6227279"/>
+                    <a:pt x="-1371" y="4832927"/>
+                    <a:pt x="-1371" y="3112940"/>
+                  </a:cubicBezTo>
+                  <a:close/>
+                </a:path>
+              </a:pathLst>
+            </a:custGeom>
+            <a:solidFill>
+              <a:srgbClr val="4472C4">
+                <a:alpha val="15000"/>
+              </a:srgbClr>
+            </a:solidFill>
+            <a:ln w="8067" cap="flat">
+              <a:noFill/>
+              <a:prstDash val="solid"/>
+              <a:miter/>
+            </a:ln>
+          </p:spPr>
+          <p:txBody>
+            <a:bodyPr/>
+            <a:lstStyle/>
+            <a:p>
+              <a:endParaRPr lang="en-US"/>
+            </a:p>
+          </p:txBody>
+        </p:sp>
+        <p:pic>
+          <p:nvPicPr>
+            <p:cNvPr id="53" name="Graphic 52" descr="Hierarchy outline">
+              <a:extLst>
+                <a:ext uri="{FF2B5EF4-FFF2-40B4-BE49-F238E27FC236}">
+                  <a16:creationId xmlns:a16="http://schemas.microsoft.com/office/drawing/2014/main" id="{B4FA1865-06E0-410E-0884-7ED3E9039DA3}"/>
+                </a:ext>
+              </a:extLst>
+            </p:cNvPr>
+            <p:cNvPicPr>
+              <a:picLocks noChangeAspect="1"/>
+            </p:cNvPicPr>
+            <p:nvPr/>
+          </p:nvPicPr>
+          <p:blipFill>
+            <a:blip>
+              <a:extLst>
+                <a:ext uri="{96DAC541-7B7A-43D3-8B79-37D633B846F1}">
+                  <asvg:svgBlip xmlns:asvg="http://schemas.microsoft.com/office/drawing/2016/SVG/main" r:embed="rId2"/>
+                </a:ext>
+              </a:extLst>
+            </a:blip>
+            <a:stretch>
+              <a:fillRect/>
+            </a:stretch>
+          </p:blipFill>
+          <p:spPr>
+            <a:xfrm>
+              <a:off x="4103587" y="914400"/>
+              <a:ext cx="5029200" cy="5029200"/>
+            </a:xfrm>
+            <a:prstGeom prst="rect">
+              <a:avLst/>
+            </a:prstGeom>
+            <a:effectLst>
+              <a:outerShdw blurRad="50800" dist="127000" dir="2700000" algn="tl" rotWithShape="0">
+                <a:schemeClr val="accent1">
+                  <a:alpha val="40000"/>
+                </a:schemeClr>
+              </a:outerShdw>
+            </a:effectLst>
+          </p:spPr>
+        </p:pic>
+      </p:grpSp>
     </p:spTree>
     <p:extLst>
       <p:ext uri="{BB962C8B-B14F-4D97-AF65-F5344CB8AC3E}">

</xml_diff>